<commit_message>
feat: add project presentation file to share directory
</commit_message>
<xml_diff>
--- a/share/SIH26-A0H-T226__Presentation.pptx
+++ b/share/SIH26-A0H-T226__Presentation.pptx
@@ -621,6 +621,13 @@
             <a:tailEnd/>
           </a:ln>
         </p:spPr>
+        <p:txBody>
+          <a:bodyPr/>
+          <a:lstStyle/>
+          <a:p>
+            <a:endParaRPr lang="en-IN"/>
+          </a:p>
+        </p:txBody>
       </p:sp>
       <p:sp>
         <p:nvSpPr>
@@ -740,6 +747,13 @@
             <a:tailEnd/>
           </a:ln>
         </p:spPr>
+        <p:txBody>
+          <a:bodyPr/>
+          <a:lstStyle/>
+          <a:p>
+            <a:endParaRPr lang="en-IN"/>
+          </a:p>
+        </p:txBody>
       </p:sp>
       <p:sp>
         <p:nvSpPr>
@@ -859,6 +873,13 @@
             <a:tailEnd/>
           </a:ln>
         </p:spPr>
+        <p:txBody>
+          <a:bodyPr/>
+          <a:lstStyle/>
+          <a:p>
+            <a:endParaRPr lang="en-IN"/>
+          </a:p>
+        </p:txBody>
       </p:sp>
       <p:sp>
         <p:nvSpPr>
@@ -1037,6 +1058,13 @@
             <a:tailEnd/>
           </a:ln>
         </p:spPr>
+        <p:txBody>
+          <a:bodyPr/>
+          <a:lstStyle/>
+          <a:p>
+            <a:endParaRPr lang="en-IN"/>
+          </a:p>
+        </p:txBody>
       </p:sp>
       <p:sp>
         <p:nvSpPr>
@@ -1215,6 +1243,13 @@
             <a:tailEnd/>
           </a:ln>
         </p:spPr>
+        <p:txBody>
+          <a:bodyPr/>
+          <a:lstStyle/>
+          <a:p>
+            <a:endParaRPr lang="en-IN"/>
+          </a:p>
+        </p:txBody>
       </p:sp>
       <p:sp>
         <p:nvSpPr>
@@ -5765,7 +5800,7 @@
               <a:t>Team Name - </a:t>
             </a:r>
             <a:r>
-              <a:rPr lang="en-US" sz="2000" dirty="0" err="1">
+              <a:rPr lang="en-US" sz="2000" dirty="0">
                 <a:latin typeface="Arial" panose="020B0604020202020204" pitchFamily="34" charset="0"/>
                 <a:cs typeface="Arial" panose="020B0604020202020204" pitchFamily="34" charset="0"/>
               </a:rPr>
@@ -5964,45 +5999,6 @@
       </p:sp>
       <p:sp>
         <p:nvSpPr>
-          <p:cNvPr id="7" name="Footer Placeholder 6"/>
-          <p:cNvSpPr>
-            <a:spLocks noGrp="1"/>
-          </p:cNvSpPr>
-          <p:nvPr>
-            <p:ph type="ftr" sz="quarter" idx="11"/>
-          </p:nvPr>
-        </p:nvSpPr>
-        <p:spPr>
-          <a:xfrm>
-            <a:off x="4648200" y="6356353"/>
-            <a:ext cx="3204000" cy="365125"/>
-          </a:xfrm>
-        </p:spPr>
-        <p:txBody>
-          <a:bodyPr/>
-          <a:lstStyle/>
-          <a:p>
-            <a:pPr>
-              <a:defRPr/>
-            </a:pPr>
-            <a:r>
-              <a:rPr lang="en-US">
-                <a:solidFill>
-                  <a:schemeClr val="bg1"/>
-                </a:solidFill>
-              </a:rPr>
-              <a:t>@SIH Idea submission- Template</a:t>
-            </a:r>
-            <a:endParaRPr lang="en-US" dirty="0">
-              <a:solidFill>
-                <a:schemeClr val="bg1"/>
-              </a:solidFill>
-            </a:endParaRPr>
-          </a:p>
-        </p:txBody>
-      </p:sp>
-      <p:sp>
-        <p:nvSpPr>
           <p:cNvPr id="10" name="Oval 9" descr="Your startup LOGO">
             <a:extLst>
               <a:ext uri="{FF2B5EF4-FFF2-40B4-BE49-F238E27FC236}">
@@ -6045,7 +6041,7 @@
           <a:p>
             <a:pPr algn="ctr"/>
             <a:r>
-              <a:rPr lang="en-US" sz="1600" dirty="0" err="1"/>
+              <a:rPr lang="en-US" sz="1600" dirty="0"/>
               <a:t>ForgeByte</a:t>
             </a:r>
             <a:endParaRPr lang="en-IN" sz="1600" dirty="0"/>
@@ -6082,8 +6078,8 @@
           </a:prstGeom>
         </p:spPr>
       </p:pic>
-      <mc:AlternateContent xmlns:mc="http://schemas.openxmlformats.org/markup-compatibility/2006" xmlns:a14="http://schemas.microsoft.com/office/drawing/2010/main">
-        <mc:Choice Requires="a14">
+      <mc:AlternateContent xmlns:mc="http://schemas.openxmlformats.org/markup-compatibility/2006">
+        <mc:Choice xmlns:a14="http://schemas.microsoft.com/office/drawing/2010/main" Requires="a14">
           <p:sp>
             <p:nvSpPr>
               <p:cNvPr id="2" name="Rectangle: Rounded Corners 1">
@@ -6210,7 +6206,7 @@
                 </a:r>
                 <a:r>
                   <a:rPr lang="en-IN" sz="1400" dirty="0"/>
-                  <a:t> Master self-hosts a local Wi-Fi dashboard (192.168.4.1), OLED display, and 4-tier status LEDs (🟢 Normal , 🔴 Critical) with zero internet/cloud dependency.</a:t>
+                  <a:t> Master self-hosts a local Wi-Fi dashboard (192.168.4.1), OLED display, and 4-tier status LEDs (Normal ,  Critical) with zero internet/cloud dependency.</a:t>
                 </a:r>
               </a:p>
               <a:p>
@@ -6220,7 +6216,7 @@
             </p:txBody>
           </p:sp>
         </mc:Choice>
-        <mc:Fallback xmlns="">
+        <mc:Fallback>
           <p:sp>
             <p:nvSpPr>
               <p:cNvPr id="2" name="Rectangle: Rounded Corners 1">
@@ -6460,8 +6456,8 @@
         </p:nvSpPr>
         <p:spPr>
           <a:xfrm>
-            <a:off x="717755" y="1327355"/>
-            <a:ext cx="3108633" cy="738664"/>
+            <a:off x="717755" y="1406011"/>
+            <a:ext cx="3108633" cy="800219"/>
           </a:xfrm>
           <a:prstGeom prst="rect">
             <a:avLst/>
@@ -6476,7 +6472,7 @@
           <a:p>
             <a:pPr algn="ctr"/>
             <a:r>
-              <a:rPr lang="en-IN" sz="1400" b="1" dirty="0"/>
+              <a:rPr lang="en-IN" sz="1600" b="1" dirty="0"/>
               <a:t>Detailed Explanation of Proposed Solution</a:t>
             </a:r>
           </a:p>
@@ -6499,8 +6495,8 @@
         </p:nvSpPr>
         <p:spPr>
           <a:xfrm>
-            <a:off x="4695883" y="1425590"/>
-            <a:ext cx="3108633" cy="307777"/>
+            <a:off x="4743567" y="1500176"/>
+            <a:ext cx="3108633" cy="338554"/>
           </a:xfrm>
           <a:prstGeom prst="rect">
             <a:avLst/>
@@ -6514,7 +6510,7 @@
           <a:lstStyle/>
           <a:p>
             <a:r>
-              <a:rPr lang="en-IN" sz="1400" b="1" dirty="0"/>
+              <a:rPr lang="en-IN" sz="1600" b="1" dirty="0"/>
               <a:t>How It Addresses the Problem</a:t>
             </a:r>
           </a:p>
@@ -6534,8 +6530,8 @@
         </p:nvSpPr>
         <p:spPr>
           <a:xfrm>
-            <a:off x="8737600" y="1483095"/>
-            <a:ext cx="3108633" cy="307777"/>
+            <a:off x="8605683" y="1483095"/>
+            <a:ext cx="3108633" cy="338554"/>
           </a:xfrm>
           <a:prstGeom prst="rect">
             <a:avLst/>
@@ -6550,7 +6546,7 @@
           <a:p>
             <a:pPr algn="ctr"/>
             <a:r>
-              <a:rPr lang="en-IN" sz="1400" b="1" dirty="0"/>
+              <a:rPr lang="en-IN" sz="1600" b="1" dirty="0"/>
               <a:t>Innovation &amp; Uniqueness</a:t>
             </a:r>
           </a:p>
@@ -6697,45 +6693,6 @@
               <a:t>3</a:t>
             </a:fld>
             <a:endParaRPr lang="en-US" b="1" dirty="0">
-              <a:solidFill>
-                <a:schemeClr val="bg1"/>
-              </a:solidFill>
-            </a:endParaRPr>
-          </a:p>
-        </p:txBody>
-      </p:sp>
-      <p:sp>
-        <p:nvSpPr>
-          <p:cNvPr id="7" name="Footer Placeholder 6"/>
-          <p:cNvSpPr>
-            <a:spLocks noGrp="1"/>
-          </p:cNvSpPr>
-          <p:nvPr>
-            <p:ph type="ftr" sz="quarter" idx="11"/>
-          </p:nvPr>
-        </p:nvSpPr>
-        <p:spPr>
-          <a:xfrm>
-            <a:off x="4648200" y="6356353"/>
-            <a:ext cx="3204000" cy="365125"/>
-          </a:xfrm>
-        </p:spPr>
-        <p:txBody>
-          <a:bodyPr/>
-          <a:lstStyle/>
-          <a:p>
-            <a:pPr>
-              <a:defRPr/>
-            </a:pPr>
-            <a:r>
-              <a:rPr lang="en-US">
-                <a:solidFill>
-                  <a:schemeClr val="bg1"/>
-                </a:solidFill>
-              </a:rPr>
-              <a:t>@SIH Idea submission- Template</a:t>
-            </a:r>
-            <a:endParaRPr lang="en-US" dirty="0">
               <a:solidFill>
                 <a:schemeClr val="bg1"/>
               </a:solidFill>
@@ -6817,7 +6774,7 @@
           <a:p>
             <a:pPr algn="ctr"/>
             <a:r>
-              <a:rPr lang="en-US" sz="1600" dirty="0" err="1"/>
+              <a:rPr lang="en-US" sz="1600" dirty="0"/>
               <a:t>ForgeByte</a:t>
             </a:r>
             <a:endParaRPr lang="en-IN" sz="1600" dirty="0"/>
@@ -7275,8 +7232,8 @@
         </p:nvSpPr>
         <p:spPr bwMode="auto">
           <a:xfrm>
-            <a:off x="339605" y="1772866"/>
-            <a:ext cx="5068137" cy="3847207"/>
+            <a:off x="339605" y="1552735"/>
+            <a:ext cx="4547027" cy="4308872"/>
           </a:xfrm>
           <a:prstGeom prst="rect">
             <a:avLst/>
@@ -7476,77 +7433,6 @@
           </a:p>
         </p:txBody>
       </p:sp>
-      <p:sp>
-        <p:nvSpPr>
-          <p:cNvPr id="7" name="Footer Placeholder 6"/>
-          <p:cNvSpPr>
-            <a:spLocks noGrp="1"/>
-          </p:cNvSpPr>
-          <p:nvPr>
-            <p:ph type="ftr" sz="quarter" idx="11"/>
-          </p:nvPr>
-        </p:nvSpPr>
-        <p:spPr>
-          <a:xfrm>
-            <a:off x="4648200" y="6356353"/>
-            <a:ext cx="3204000" cy="365125"/>
-          </a:xfrm>
-        </p:spPr>
-        <p:txBody>
-          <a:bodyPr/>
-          <a:lstStyle/>
-          <a:p>
-            <a:pPr marL="0" marR="0" lvl="0" indent="0" algn="ctr" defTabSz="457200" rtl="0" eaLnBrk="1" fontAlgn="auto" latinLnBrk="0" hangingPunct="1">
-              <a:lnSpc>
-                <a:spcPct val="100000"/>
-              </a:lnSpc>
-              <a:spcBef>
-                <a:spcPts val="0"/>
-              </a:spcBef>
-              <a:spcAft>
-                <a:spcPts val="0"/>
-              </a:spcAft>
-              <a:buClrTx/>
-              <a:buSzTx/>
-              <a:buFontTx/>
-              <a:buNone/>
-              <a:tabLst/>
-              <a:defRPr/>
-            </a:pPr>
-            <a:r>
-              <a:rPr kumimoji="0" lang="en-US" sz="1200" b="0" i="0" u="none" strike="noStrike" kern="1200" cap="none" spc="0" normalizeH="0" baseline="0" noProof="0">
-                <a:ln>
-                  <a:noFill/>
-                </a:ln>
-                <a:solidFill>
-                  <a:prstClr val="white"/>
-                </a:solidFill>
-                <a:effectLst/>
-                <a:uLnTx/>
-                <a:uFillTx/>
-                <a:latin typeface="TradeGothic"/>
-                <a:ea typeface="+mn-ea"/>
-                <a:cs typeface="+mn-cs"/>
-              </a:rPr>
-              <a:t>@SIH Idea submission- Template</a:t>
-            </a:r>
-            <a:endParaRPr kumimoji="0" lang="en-US" sz="1200" b="0" i="0" u="none" strike="noStrike" kern="1200" cap="none" spc="0" normalizeH="0" baseline="0" noProof="0" dirty="0">
-              <a:ln>
-                <a:noFill/>
-              </a:ln>
-              <a:solidFill>
-                <a:prstClr val="white"/>
-              </a:solidFill>
-              <a:effectLst/>
-              <a:uLnTx/>
-              <a:uFillTx/>
-              <a:latin typeface="TradeGothic"/>
-              <a:ea typeface="+mn-ea"/>
-              <a:cs typeface="+mn-cs"/>
-            </a:endParaRPr>
-          </a:p>
-        </p:txBody>
-      </p:sp>
       <p:pic>
         <p:nvPicPr>
           <p:cNvPr id="11" name="Picture 10"/>
@@ -7621,7 +7507,7 @@
           <a:p>
             <a:pPr algn="ctr"/>
             <a:r>
-              <a:rPr lang="en-US" sz="1600" dirty="0" err="1"/>
+              <a:rPr lang="en-US" sz="1600" dirty="0"/>
               <a:t>ForgeByte</a:t>
             </a:r>
             <a:endParaRPr lang="en-IN" sz="1600" dirty="0"/>
@@ -7645,35 +7531,35 @@
               <p:nvPr>
                 <p:extLst>
                   <p:ext uri="{D42A27DB-BD31-4B8C-83A1-F6EECF244321}">
-                    <p14:modId xmlns:p14="http://schemas.microsoft.com/office/powerpoint/2010/main" val="2016740129"/>
+                    <p14:modId xmlns:p14="http://schemas.microsoft.com/office/powerpoint/2010/main" val="767296084"/>
                   </p:ext>
                 </p:extLst>
               </p:nvPr>
             </p:nvGraphicFramePr>
             <p:xfrm>
-              <a:off x="5677738" y="1093605"/>
-              <a:ext cx="6352200" cy="5205730"/>
+              <a:off x="5112774" y="1144500"/>
+              <a:ext cx="6917163" cy="4943718"/>
             </p:xfrm>
             <a:graphic>
               <a:graphicData uri="http://schemas.openxmlformats.org/drawingml/2006/table">
                 <a:tbl>
                   <a:tblPr firstRow="1" firstCol="1" bandRow="1"/>
                   <a:tblGrid>
-                    <a:gridCol w="2117400">
+                    <a:gridCol w="2305721">
                       <a:extLst>
                         <a:ext uri="{9D8B030D-6E8A-4147-A177-3AD203B41FA5}">
                           <a16:colId xmlns:a16="http://schemas.microsoft.com/office/drawing/2014/main" val="2860664286"/>
                         </a:ext>
                       </a:extLst>
                     </a:gridCol>
-                    <a:gridCol w="2117400">
+                    <a:gridCol w="2305721">
                       <a:extLst>
                         <a:ext uri="{9D8B030D-6E8A-4147-A177-3AD203B41FA5}">
                           <a16:colId xmlns:a16="http://schemas.microsoft.com/office/drawing/2014/main" val="1013833407"/>
                         </a:ext>
                       </a:extLst>
                     </a:gridCol>
-                    <a:gridCol w="2117400">
+                    <a:gridCol w="2305721">
                       <a:extLst>
                         <a:ext uri="{9D8B030D-6E8A-4147-A177-3AD203B41FA5}">
                           <a16:colId xmlns:a16="http://schemas.microsoft.com/office/drawing/2014/main" val="962404475"/>
@@ -7681,7 +7567,7 @@
                       </a:extLst>
                     </a:gridCol>
                   </a:tblGrid>
-                  <a:tr h="197135">
+                  <a:tr h="189237">
                     <a:tc>
                       <a:txBody>
                         <a:bodyPr/>
@@ -7883,13 +7769,13 @@
                       </a:ext>
                     </a:extLst>
                   </a:tr>
-                  <a:tr h="1026757">
+                  <a:tr h="985618">
                     <a:tc>
                       <a:txBody>
                         <a:bodyPr/>
                         <a:lstStyle/>
                         <a:p>
-                          <a:pPr algn="l">
+                          <a:pPr algn="ctr">
                             <a:lnSpc>
                               <a:spcPct val="115000"/>
                             </a:lnSpc>
@@ -7960,7 +7846,7 @@
                         <a:bodyPr/>
                         <a:lstStyle/>
                         <a:p>
-                          <a:pPr algn="l">
+                          <a:pPr algn="ctr">
                             <a:lnSpc>
                               <a:spcPct val="115000"/>
                             </a:lnSpc>
@@ -8025,7 +7911,7 @@
                         <a:bodyPr/>
                         <a:lstStyle/>
                         <a:p>
-                          <a:pPr algn="l">
+                          <a:pPr algn="ctr">
                             <a:lnSpc>
                               <a:spcPct val="115000"/>
                             </a:lnSpc>
@@ -8035,7 +7921,7 @@
                             <a:buNone/>
                           </a:pPr>
                           <a:r>
-                            <a:rPr lang="en-IN" sz="1200" b="1" kern="100">
+                            <a:rPr lang="en-IN" sz="1200" b="1" kern="100" dirty="0">
                               <a:effectLst/>
                               <a:latin typeface="Aptos" panose="020B0004020202020204" pitchFamily="34" charset="0"/>
                               <a:ea typeface="Aptos" panose="020B0004020202020204" pitchFamily="34" charset="0"/>
@@ -8044,7 +7930,7 @@
                             <a:t>IP65-Rated Weatherproof Enclosure</a:t>
                           </a:r>
                           <a:r>
-                            <a:rPr lang="en-IN" sz="1200" kern="100">
+                            <a:rPr lang="en-IN" sz="1200" kern="100" dirty="0">
                               <a:effectLst/>
                               <a:latin typeface="Aptos" panose="020B0004020202020204" pitchFamily="34" charset="0"/>
                               <a:ea typeface="Aptos" panose="020B0004020202020204" pitchFamily="34" charset="0"/>
@@ -8100,13 +7986,13 @@
                       </a:ext>
                     </a:extLst>
                   </a:tr>
-                  <a:tr h="1235550">
+                  <a:tr h="1169653">
                     <a:tc>
                       <a:txBody>
                         <a:bodyPr/>
                         <a:lstStyle/>
                         <a:p>
-                          <a:pPr algn="l">
+                          <a:pPr algn="ctr">
                             <a:lnSpc>
                               <a:spcPct val="115000"/>
                             </a:lnSpc>
@@ -8177,7 +8063,7 @@
                         <a:bodyPr/>
                         <a:lstStyle/>
                         <a:p>
-                          <a:pPr algn="l">
+                          <a:pPr algn="ctr">
                             <a:lnSpc>
                               <a:spcPct val="115000"/>
                             </a:lnSpc>
@@ -8242,7 +8128,7 @@
                         <a:bodyPr/>
                         <a:lstStyle/>
                         <a:p>
-                          <a:pPr algn="l">
+                          <a:pPr algn="ctr">
                             <a:lnSpc>
                               <a:spcPct val="115000"/>
                             </a:lnSpc>
@@ -8381,13 +8267,13 @@
                       </a:ext>
                     </a:extLst>
                   </a:tr>
-                  <a:tr h="1441567">
+                  <a:tr h="1364682">
                     <a:tc>
                       <a:txBody>
                         <a:bodyPr/>
                         <a:lstStyle/>
                         <a:p>
-                          <a:pPr algn="l">
+                          <a:pPr algn="ctr">
                             <a:lnSpc>
                               <a:spcPct val="115000"/>
                             </a:lnSpc>
@@ -8458,7 +8344,7 @@
                         <a:bodyPr/>
                         <a:lstStyle/>
                         <a:p>
-                          <a:pPr algn="l">
+                          <a:pPr algn="ctr">
                             <a:lnSpc>
                               <a:spcPct val="115000"/>
                             </a:lnSpc>
@@ -8468,7 +8354,7 @@
                             <a:buNone/>
                           </a:pPr>
                           <a:r>
-                            <a:rPr lang="en-IN" sz="1200" kern="100">
+                            <a:rPr lang="en-IN" sz="1200" kern="100" dirty="0">
                               <a:effectLst/>
                               <a:latin typeface="Aptos" panose="020B0004020202020204" pitchFamily="34" charset="0"/>
                               <a:ea typeface="Aptos" panose="020B0004020202020204" pitchFamily="34" charset="0"/>
@@ -8523,7 +8409,7 @@
                         <a:bodyPr/>
                         <a:lstStyle/>
                         <a:p>
-                          <a:pPr algn="l">
+                          <a:pPr algn="ctr">
                             <a:lnSpc>
                               <a:spcPct val="115000"/>
                             </a:lnSpc>
@@ -8548,25 +8434,7 @@
                               <a:ea typeface="Aptos" panose="020B0004020202020204" pitchFamily="34" charset="0"/>
                               <a:cs typeface="Times New Roman" panose="02020603050405020304" pitchFamily="18" charset="0"/>
                             </a:rPr>
-                            <a:t> Automated dynamic rerouting to alternate </a:t>
-                          </a:r>
-                          <a:r>
-                            <a:rPr lang="en-IN" sz="1200" kern="100" dirty="0" err="1">
-                              <a:effectLst/>
-                              <a:latin typeface="Aptos" panose="020B0004020202020204" pitchFamily="34" charset="0"/>
-                              <a:ea typeface="Aptos" panose="020B0004020202020204" pitchFamily="34" charset="0"/>
-                              <a:cs typeface="Times New Roman" panose="02020603050405020304" pitchFamily="18" charset="0"/>
-                            </a:rPr>
-                            <a:t>neighbor</a:t>
-                          </a:r>
-                          <a:r>
-                            <a:rPr lang="en-IN" sz="1200" kern="100" dirty="0">
-                              <a:effectLst/>
-                              <a:latin typeface="Aptos" panose="020B0004020202020204" pitchFamily="34" charset="0"/>
-                              <a:ea typeface="Aptos" panose="020B0004020202020204" pitchFamily="34" charset="0"/>
-                              <a:cs typeface="Times New Roman" panose="02020603050405020304" pitchFamily="18" charset="0"/>
-                            </a:rPr>
-                            <a:t> nodes; Master OLED immediately alerts </a:t>
+                            <a:t> Automated dynamic rerouting to alternate neighbour nodes; Master OLED immediately alerts </a:t>
                           </a:r>
                           <a:r>
                             <a:rPr lang="en-IN" sz="1200" i="1" kern="100" dirty="0">
@@ -8634,13 +8502,13 @@
                       </a:ext>
                     </a:extLst>
                   </a:tr>
-                  <a:tr h="1234162">
+                  <a:tr h="1168339">
                     <a:tc>
                       <a:txBody>
                         <a:bodyPr/>
                         <a:lstStyle/>
                         <a:p>
-                          <a:pPr algn="l">
+                          <a:pPr algn="ctr">
                             <a:lnSpc>
                               <a:spcPct val="115000"/>
                             </a:lnSpc>
@@ -8711,7 +8579,7 @@
                         <a:bodyPr/>
                         <a:lstStyle/>
                         <a:p>
-                          <a:pPr algn="l">
+                          <a:pPr algn="ctr">
                             <a:lnSpc>
                               <a:spcPct val="115000"/>
                             </a:lnSpc>
@@ -8776,7 +8644,7 @@
                         <a:bodyPr/>
                         <a:lstStyle/>
                         <a:p>
-                          <a:pPr algn="l">
+                          <a:pPr algn="ctr">
                             <a:lnSpc>
                               <a:spcPct val="115000"/>
                             </a:lnSpc>
@@ -8872,35 +8740,35 @@
               <p:nvPr>
                 <p:extLst>
                   <p:ext uri="{D42A27DB-BD31-4B8C-83A1-F6EECF244321}">
-                    <p14:modId xmlns:p14="http://schemas.microsoft.com/office/powerpoint/2010/main" val="2016740129"/>
+                    <p14:modId xmlns:p14="http://schemas.microsoft.com/office/powerpoint/2010/main" val="767296084"/>
                   </p:ext>
                 </p:extLst>
               </p:nvPr>
             </p:nvGraphicFramePr>
             <p:xfrm>
-              <a:off x="5677738" y="1093605"/>
-              <a:ext cx="6352200" cy="5205730"/>
+              <a:off x="5112774" y="1144500"/>
+              <a:ext cx="6917163" cy="4943718"/>
             </p:xfrm>
             <a:graphic>
               <a:graphicData uri="http://schemas.openxmlformats.org/drawingml/2006/table">
                 <a:tbl>
                   <a:tblPr firstRow="1" firstCol="1" bandRow="1"/>
                   <a:tblGrid>
-                    <a:gridCol w="2117400">
+                    <a:gridCol w="2305721">
                       <a:extLst>
                         <a:ext uri="{9D8B030D-6E8A-4147-A177-3AD203B41FA5}">
                           <a16:colId xmlns:a16="http://schemas.microsoft.com/office/drawing/2014/main" val="2860664286"/>
                         </a:ext>
                       </a:extLst>
                     </a:gridCol>
-                    <a:gridCol w="2117400">
+                    <a:gridCol w="2305721">
                       <a:extLst>
                         <a:ext uri="{9D8B030D-6E8A-4147-A177-3AD203B41FA5}">
                           <a16:colId xmlns:a16="http://schemas.microsoft.com/office/drawing/2014/main" val="1013833407"/>
                         </a:ext>
                       </a:extLst>
                     </a:gridCol>
-                    <a:gridCol w="2117400">
+                    <a:gridCol w="2305721">
                       <a:extLst>
                         <a:ext uri="{9D8B030D-6E8A-4147-A177-3AD203B41FA5}">
                           <a16:colId xmlns:a16="http://schemas.microsoft.com/office/drawing/2014/main" val="962404475"/>
@@ -9116,7 +8984,7 @@
                         <a:bodyPr/>
                         <a:lstStyle/>
                         <a:p>
-                          <a:pPr algn="l">
+                          <a:pPr algn="ctr">
                             <a:lnSpc>
                               <a:spcPct val="115000"/>
                             </a:lnSpc>
@@ -9187,7 +9055,7 @@
                         <a:bodyPr/>
                         <a:lstStyle/>
                         <a:p>
-                          <a:pPr algn="l">
+                          <a:pPr algn="ctr">
                             <a:lnSpc>
                               <a:spcPct val="115000"/>
                             </a:lnSpc>
@@ -9252,7 +9120,7 @@
                         <a:bodyPr/>
                         <a:lstStyle/>
                         <a:p>
-                          <a:pPr algn="l">
+                          <a:pPr algn="ctr">
                             <a:lnSpc>
                               <a:spcPct val="115000"/>
                             </a:lnSpc>
@@ -9262,7 +9130,7 @@
                             <a:buNone/>
                           </a:pPr>
                           <a:r>
-                            <a:rPr lang="en-IN" sz="1200" b="1" kern="100">
+                            <a:rPr lang="en-IN" sz="1200" b="1" kern="100" dirty="0">
                               <a:effectLst/>
                               <a:latin typeface="Aptos" panose="020B0004020202020204" pitchFamily="34" charset="0"/>
                               <a:ea typeface="Aptos" panose="020B0004020202020204" pitchFamily="34" charset="0"/>
@@ -9271,7 +9139,7 @@
                             <a:t>IP65-Rated Weatherproof Enclosure</a:t>
                           </a:r>
                           <a:r>
-                            <a:rPr lang="en-IN" sz="1200" kern="100">
+                            <a:rPr lang="en-IN" sz="1200" kern="100" dirty="0">
                               <a:effectLst/>
                               <a:latin typeface="Aptos" panose="020B0004020202020204" pitchFamily="34" charset="0"/>
                               <a:ea typeface="Aptos" panose="020B0004020202020204" pitchFamily="34" charset="0"/>
@@ -9327,13 +9195,13 @@
                       </a:ext>
                     </a:extLst>
                   </a:tr>
-                  <a:tr h="1251458">
+                  <a:tr h="1169653">
                     <a:tc>
                       <a:txBody>
                         <a:bodyPr/>
                         <a:lstStyle/>
                         <a:p>
-                          <a:pPr algn="l">
+                          <a:pPr algn="ctr">
                             <a:lnSpc>
                               <a:spcPct val="115000"/>
                             </a:lnSpc>
@@ -9404,7 +9272,7 @@
                         <a:bodyPr/>
                         <a:lstStyle/>
                         <a:p>
-                          <a:pPr algn="l">
+                          <a:pPr algn="ctr">
                             <a:lnSpc>
                               <a:spcPct val="115000"/>
                             </a:lnSpc>
@@ -9512,7 +9380,7 @@
                         <a:blipFill>
                           <a:blip r:embed="rId4"/>
                           <a:stretch>
-                            <a:fillRect l="-200000" t="-101951" r="-575" b="-224878"/>
+                            <a:fillRect l="-200000" t="-108333" r="-528" b="-219271"/>
                           </a:stretch>
                         </a:blipFill>
                       </a:tcPr>
@@ -9523,13 +9391,13 @@
                       </a:ext>
                     </a:extLst>
                   </a:tr>
-                  <a:tr h="1461770">
+                  <a:tr h="1364682">
                     <a:tc>
                       <a:txBody>
                         <a:bodyPr/>
                         <a:lstStyle/>
                         <a:p>
-                          <a:pPr algn="l">
+                          <a:pPr algn="ctr">
                             <a:lnSpc>
                               <a:spcPct val="115000"/>
                             </a:lnSpc>
@@ -9600,7 +9468,7 @@
                         <a:bodyPr/>
                         <a:lstStyle/>
                         <a:p>
-                          <a:pPr algn="l">
+                          <a:pPr algn="ctr">
                             <a:lnSpc>
                               <a:spcPct val="115000"/>
                             </a:lnSpc>
@@ -9610,7 +9478,7 @@
                             <a:buNone/>
                           </a:pPr>
                           <a:r>
-                            <a:rPr lang="en-IN" sz="1200" kern="100">
+                            <a:rPr lang="en-IN" sz="1200" kern="100" dirty="0">
                               <a:effectLst/>
                               <a:latin typeface="Aptos" panose="020B0004020202020204" pitchFamily="34" charset="0"/>
                               <a:ea typeface="Aptos" panose="020B0004020202020204" pitchFamily="34" charset="0"/>
@@ -9665,7 +9533,7 @@
                         <a:bodyPr/>
                         <a:lstStyle/>
                         <a:p>
-                          <a:pPr algn="l">
+                          <a:pPr algn="ctr">
                             <a:lnSpc>
                               <a:spcPct val="115000"/>
                             </a:lnSpc>
@@ -9690,25 +9558,7 @@
                               <a:ea typeface="Aptos" panose="020B0004020202020204" pitchFamily="34" charset="0"/>
                               <a:cs typeface="Times New Roman" panose="02020603050405020304" pitchFamily="18" charset="0"/>
                             </a:rPr>
-                            <a:t> Automated dynamic rerouting to alternate </a:t>
-                          </a:r>
-                          <a:r>
-                            <a:rPr lang="en-IN" sz="1200" kern="100" dirty="0" err="1">
-                              <a:effectLst/>
-                              <a:latin typeface="Aptos" panose="020B0004020202020204" pitchFamily="34" charset="0"/>
-                              <a:ea typeface="Aptos" panose="020B0004020202020204" pitchFamily="34" charset="0"/>
-                              <a:cs typeface="Times New Roman" panose="02020603050405020304" pitchFamily="18" charset="0"/>
-                            </a:rPr>
-                            <a:t>neighbor</a:t>
-                          </a:r>
-                          <a:r>
-                            <a:rPr lang="en-IN" sz="1200" kern="100" dirty="0">
-                              <a:effectLst/>
-                              <a:latin typeface="Aptos" panose="020B0004020202020204" pitchFamily="34" charset="0"/>
-                              <a:ea typeface="Aptos" panose="020B0004020202020204" pitchFamily="34" charset="0"/>
-                              <a:cs typeface="Times New Roman" panose="02020603050405020304" pitchFamily="18" charset="0"/>
-                            </a:rPr>
-                            <a:t> nodes; Master OLED immediately alerts </a:t>
+                            <a:t> Automated dynamic rerouting to alternate neighbour nodes; Master OLED immediately alerts </a:t>
                           </a:r>
                           <a:r>
                             <a:rPr lang="en-IN" sz="1200" i="1" kern="100" dirty="0">
@@ -9776,13 +9626,13 @@
                       </a:ext>
                     </a:extLst>
                   </a:tr>
-                  <a:tr h="1251458">
+                  <a:tr h="1168339">
                     <a:tc>
                       <a:txBody>
                         <a:bodyPr/>
                         <a:lstStyle/>
                         <a:p>
-                          <a:pPr algn="l">
+                          <a:pPr algn="ctr">
                             <a:lnSpc>
                               <a:spcPct val="115000"/>
                             </a:lnSpc>
@@ -9853,7 +9703,7 @@
                         <a:bodyPr/>
                         <a:lstStyle/>
                         <a:p>
-                          <a:pPr algn="l">
+                          <a:pPr algn="ctr">
                             <a:lnSpc>
                               <a:spcPct val="115000"/>
                             </a:lnSpc>
@@ -9918,7 +9768,7 @@
                         <a:bodyPr/>
                         <a:lstStyle/>
                         <a:p>
-                          <a:pPr algn="l">
+                          <a:pPr algn="ctr">
                             <a:lnSpc>
                               <a:spcPct val="115000"/>
                             </a:lnSpc>
@@ -10131,87 +9981,6 @@
                 <a:cs typeface="Times New Roman" panose="02020603050405020304" pitchFamily="18" charset="0"/>
               </a:rPr>
               <a:t>IMPACT AND BENEFITS</a:t>
-            </a:r>
-          </a:p>
-        </p:txBody>
-      </p:sp>
-      <p:sp>
-        <p:nvSpPr>
-          <p:cNvPr id="17410" name="TextBox 8"/>
-          <p:cNvSpPr txBox="1">
-            <a:spLocks noChangeArrowheads="1"/>
-          </p:cNvSpPr>
-          <p:nvPr/>
-        </p:nvSpPr>
-        <p:spPr bwMode="auto">
-          <a:xfrm>
-            <a:off x="609600" y="2533653"/>
-            <a:ext cx="9385300" cy="2739211"/>
-          </a:xfrm>
-          <a:prstGeom prst="rect">
-            <a:avLst/>
-          </a:prstGeom>
-          <a:noFill/>
-          <a:ln w="9525">
-            <a:noFill/>
-            <a:miter lim="800000"/>
-            <a:headEnd/>
-            <a:tailEnd/>
-          </a:ln>
-        </p:spPr>
-        <p:txBody>
-          <a:bodyPr wrap="square">
-            <a:spAutoFit/>
-          </a:bodyPr>
-          <a:lstStyle/>
-          <a:p>
-            <a:r>
-              <a:rPr lang="en-IN" sz="2800" dirty="0"/>
-              <a:t>Impact on Target Audience &amp; Stakeholders</a:t>
-            </a:r>
-          </a:p>
-          <a:p>
-            <a:pPr lvl="0"/>
-            <a:r>
-              <a:rPr lang="en-IN" b="1" dirty="0"/>
-              <a:t>Mine Workers &amp; Field Crews:</a:t>
-            </a:r>
-            <a:r>
-              <a:rPr lang="en-IN" dirty="0"/>
-              <a:t> Instant on-site life safety via targeted slave sirens (e.g., Node 13 buzzer) providing crucial evacuation lead time before ground collapse.</a:t>
-            </a:r>
-          </a:p>
-          <a:p>
-            <a:pPr lvl="0"/>
-            <a:r>
-              <a:rPr lang="en-IN" b="1" dirty="0"/>
-              <a:t>Local Communities &amp; Villagers:</a:t>
-            </a:r>
-            <a:r>
-              <a:rPr lang="en-IN" dirty="0"/>
-              <a:t> Safeguards nearby residential homes, rural schools, and agricultural land from unannounced sinkhole disasters.</a:t>
-            </a:r>
-          </a:p>
-          <a:p>
-            <a:pPr lvl="0"/>
-            <a:r>
-              <a:rPr lang="en-IN" b="1" dirty="0"/>
-              <a:t>Mine Operators (Coal India Ltd / CIL):</a:t>
-            </a:r>
-            <a:r>
-              <a:rPr lang="en-IN" dirty="0"/>
-              <a:t> Provides 24/7 real-time situational awareness via offline local dashboards, preventing abrupt mine shutdowns and equipment losses.</a:t>
-            </a:r>
-          </a:p>
-          <a:p>
-            <a:pPr lvl="0"/>
-            <a:r>
-              <a:rPr lang="en-IN" b="1" dirty="0"/>
-              <a:t>Regulatory Authorities (DGMS &amp; Ministry of Coal):</a:t>
-            </a:r>
-            <a:r>
-              <a:rPr lang="en-IN" dirty="0"/>
-              <a:t> Delivers continuous, automated geotechnical risk tracking to ensure strict safety compliance.</a:t>
             </a:r>
           </a:p>
         </p:txBody>
@@ -10299,77 +10068,6 @@
           </a:p>
         </p:txBody>
       </p:sp>
-      <p:sp>
-        <p:nvSpPr>
-          <p:cNvPr id="7" name="Footer Placeholder 6"/>
-          <p:cNvSpPr>
-            <a:spLocks noGrp="1"/>
-          </p:cNvSpPr>
-          <p:nvPr>
-            <p:ph type="ftr" sz="quarter" idx="11"/>
-          </p:nvPr>
-        </p:nvSpPr>
-        <p:spPr>
-          <a:xfrm>
-            <a:off x="4648200" y="6356353"/>
-            <a:ext cx="3204000" cy="365125"/>
-          </a:xfrm>
-        </p:spPr>
-        <p:txBody>
-          <a:bodyPr/>
-          <a:lstStyle/>
-          <a:p>
-            <a:pPr marL="0" marR="0" lvl="0" indent="0" algn="ctr" defTabSz="457200" rtl="0" eaLnBrk="1" fontAlgn="auto" latinLnBrk="0" hangingPunct="1">
-              <a:lnSpc>
-                <a:spcPct val="100000"/>
-              </a:lnSpc>
-              <a:spcBef>
-                <a:spcPts val="0"/>
-              </a:spcBef>
-              <a:spcAft>
-                <a:spcPts val="0"/>
-              </a:spcAft>
-              <a:buClrTx/>
-              <a:buSzTx/>
-              <a:buFontTx/>
-              <a:buNone/>
-              <a:tabLst/>
-              <a:defRPr/>
-            </a:pPr>
-            <a:r>
-              <a:rPr kumimoji="0" lang="en-US" sz="1200" b="0" i="0" u="none" strike="noStrike" kern="1200" cap="none" spc="0" normalizeH="0" baseline="0" noProof="0">
-                <a:ln>
-                  <a:noFill/>
-                </a:ln>
-                <a:solidFill>
-                  <a:prstClr val="white"/>
-                </a:solidFill>
-                <a:effectLst/>
-                <a:uLnTx/>
-                <a:uFillTx/>
-                <a:latin typeface="TradeGothic"/>
-                <a:ea typeface="+mn-ea"/>
-                <a:cs typeface="+mn-cs"/>
-              </a:rPr>
-              <a:t>@SIH Idea submission- Template</a:t>
-            </a:r>
-            <a:endParaRPr kumimoji="0" lang="en-US" sz="1200" b="0" i="0" u="none" strike="noStrike" kern="1200" cap="none" spc="0" normalizeH="0" baseline="0" noProof="0" dirty="0">
-              <a:ln>
-                <a:noFill/>
-              </a:ln>
-              <a:solidFill>
-                <a:prstClr val="white"/>
-              </a:solidFill>
-              <a:effectLst/>
-              <a:uLnTx/>
-              <a:uFillTx/>
-              <a:latin typeface="TradeGothic"/>
-              <a:ea typeface="+mn-ea"/>
-              <a:cs typeface="+mn-cs"/>
-            </a:endParaRPr>
-          </a:p>
-        </p:txBody>
-      </p:sp>
       <p:pic>
         <p:nvPicPr>
           <p:cNvPr id="11" name="Picture 10"/>
@@ -10444,10 +10142,328 @@
           <a:p>
             <a:pPr algn="ctr"/>
             <a:r>
-              <a:rPr lang="en-US" sz="1600" dirty="0" err="1"/>
+              <a:rPr lang="en-US" sz="1600" dirty="0"/>
               <a:t>ForgeByte</a:t>
             </a:r>
             <a:endParaRPr lang="en-IN" sz="1600" dirty="0"/>
+          </a:p>
+        </p:txBody>
+      </p:sp>
+      <p:sp>
+        <p:nvSpPr>
+          <p:cNvPr id="2" name="Rectangle: Rounded Corners 1">
+            <a:extLst>
+              <a:ext uri="{FF2B5EF4-FFF2-40B4-BE49-F238E27FC236}">
+                <a16:creationId xmlns:a16="http://schemas.microsoft.com/office/drawing/2014/main" id="{A9CAADF1-9EA6-5C5E-58E5-1C10861439E2}"/>
+              </a:ext>
+            </a:extLst>
+          </p:cNvPr>
+          <p:cNvSpPr/>
+          <p:nvPr/>
+        </p:nvSpPr>
+        <p:spPr>
+          <a:xfrm>
+            <a:off x="6508954" y="1526450"/>
+            <a:ext cx="5211097" cy="4730251"/>
+          </a:xfrm>
+          <a:prstGeom prst="roundRect">
+            <a:avLst/>
+          </a:prstGeom>
+        </p:spPr>
+        <p:style>
+          <a:lnRef idx="2">
+            <a:schemeClr val="accent2"/>
+          </a:lnRef>
+          <a:fillRef idx="1">
+            <a:schemeClr val="lt1"/>
+          </a:fillRef>
+          <a:effectRef idx="0">
+            <a:schemeClr val="accent2"/>
+          </a:effectRef>
+          <a:fontRef idx="minor">
+            <a:schemeClr val="dk1"/>
+          </a:fontRef>
+        </p:style>
+        <p:txBody>
+          <a:bodyPr rtlCol="0" anchor="ctr"/>
+          <a:lstStyle/>
+          <a:p>
+            <a:pPr lvl="0" algn="just"/>
+            <a:r>
+              <a:rPr lang="en-IN" sz="1700" b="1" dirty="0"/>
+              <a:t>Mine Workers &amp; Field Crews:</a:t>
+            </a:r>
+            <a:r>
+              <a:rPr lang="en-IN" sz="1700" dirty="0"/>
+              <a:t> Instant on-site life safety via targeted slave sirens (e.g., Node 13 buzzer) providing crucial evacuation lead time before ground collapse.</a:t>
+            </a:r>
+          </a:p>
+          <a:p>
+            <a:pPr lvl="0" algn="just"/>
+            <a:r>
+              <a:rPr lang="en-IN" sz="1700" b="1" dirty="0"/>
+              <a:t>Local Communities &amp; Villagers:</a:t>
+            </a:r>
+            <a:r>
+              <a:rPr lang="en-IN" sz="1700" dirty="0"/>
+              <a:t> Safeguards nearby residential homes, rural schools, and agricultural land from unannounced sinkhole disasters.</a:t>
+            </a:r>
+          </a:p>
+          <a:p>
+            <a:pPr lvl="0" algn="just"/>
+            <a:r>
+              <a:rPr lang="en-IN" sz="1700" b="1" dirty="0"/>
+              <a:t>Mine Operators (Coal India Ltd / CIL):</a:t>
+            </a:r>
+            <a:r>
+              <a:rPr lang="en-IN" sz="1700" dirty="0"/>
+              <a:t> Provides 24/7 real-time situational awareness via offline local dashboards, preventing abrupt mine shutdowns and equipment losses.</a:t>
+            </a:r>
+          </a:p>
+          <a:p>
+            <a:pPr lvl="0" algn="just"/>
+            <a:r>
+              <a:rPr lang="en-IN" sz="1700" b="1" dirty="0"/>
+              <a:t>Regulatory Authorities (DGMS &amp; Ministry of Coal):</a:t>
+            </a:r>
+            <a:r>
+              <a:rPr lang="en-IN" sz="1700" dirty="0"/>
+              <a:t> Delivers continuous, automated geotechnical risk tracking to ensure strict safety compliance.</a:t>
+            </a:r>
+          </a:p>
+        </p:txBody>
+      </p:sp>
+      <p:sp>
+        <p:nvSpPr>
+          <p:cNvPr id="8" name="TextBox 7">
+            <a:extLst>
+              <a:ext uri="{FF2B5EF4-FFF2-40B4-BE49-F238E27FC236}">
+                <a16:creationId xmlns:a16="http://schemas.microsoft.com/office/drawing/2014/main" id="{7ECA3CC9-5656-0B79-D523-C878E38E31F6}"/>
+              </a:ext>
+            </a:extLst>
+          </p:cNvPr>
+          <p:cNvSpPr txBox="1"/>
+          <p:nvPr/>
+        </p:nvSpPr>
+        <p:spPr>
+          <a:xfrm>
+            <a:off x="403123" y="1601592"/>
+            <a:ext cx="5766227" cy="4616648"/>
+          </a:xfrm>
+          <a:prstGeom prst="rect">
+            <a:avLst/>
+          </a:prstGeom>
+          <a:noFill/>
+        </p:spPr>
+        <p:txBody>
+          <a:bodyPr wrap="square" rtlCol="0">
+            <a:spAutoFit/>
+          </a:bodyPr>
+          <a:lstStyle/>
+          <a:p>
+            <a:pPr lvl="0"/>
+            <a:r>
+              <a:rPr lang="en-IN" sz="1400" b="1" dirty="0"/>
+              <a:t>Social Benefits:</a:t>
+            </a:r>
+            <a:endParaRPr lang="en-IN" sz="1400" dirty="0"/>
+          </a:p>
+          <a:p>
+            <a:pPr lvl="1"/>
+            <a:r>
+              <a:rPr lang="en-IN" sz="1400" b="1" dirty="0"/>
+              <a:t>Zero Casualties:</a:t>
+            </a:r>
+            <a:r>
+              <a:rPr lang="en-IN" sz="1400" dirty="0"/>
+              <a:t> Drastically reduces injury and loss of life for mining personnel and surface inhabitants.</a:t>
+            </a:r>
+          </a:p>
+          <a:p>
+            <a:pPr lvl="1"/>
+            <a:r>
+              <a:rPr lang="en-IN" sz="1400" b="1" dirty="0"/>
+              <a:t>Public Trust:</a:t>
+            </a:r>
+            <a:r>
+              <a:rPr lang="en-IN" sz="1400" dirty="0"/>
+              <a:t> Builds safety confidence for communities living in subsidence-prone coal belts (e.g., </a:t>
+            </a:r>
+            <a:r>
+              <a:rPr lang="en-IN" sz="1400" dirty="0" err="1"/>
+              <a:t>Raniganj</a:t>
+            </a:r>
+            <a:r>
+              <a:rPr lang="en-IN" sz="1400" dirty="0"/>
+              <a:t>, Jharia, </a:t>
+            </a:r>
+            <a:r>
+              <a:rPr lang="en-IN" sz="1400" dirty="0" err="1"/>
+              <a:t>Singrauli</a:t>
+            </a:r>
+            <a:r>
+              <a:rPr lang="en-IN" sz="1400" dirty="0"/>
+              <a:t>).</a:t>
+            </a:r>
+          </a:p>
+          <a:p>
+            <a:pPr lvl="0"/>
+            <a:r>
+              <a:rPr lang="en-IN" sz="1400" b="1" dirty="0"/>
+              <a:t>Economic Benefits:</a:t>
+            </a:r>
+            <a:endParaRPr lang="en-IN" sz="1400" dirty="0"/>
+          </a:p>
+          <a:p>
+            <a:pPr lvl="1"/>
+            <a:r>
+              <a:rPr lang="en-IN" sz="1400" b="1" dirty="0"/>
+              <a:t>Massive Cost Savings:</a:t>
+            </a:r>
+            <a:r>
+              <a:rPr lang="en-IN" sz="1400" dirty="0"/>
+              <a:t> Prevents millions in post-disaster compensation, infrastructure repair (roads, rail lines, pipelines), and legal liabilities.</a:t>
+            </a:r>
+          </a:p>
+          <a:p>
+            <a:pPr lvl="1"/>
+            <a:r>
+              <a:rPr lang="en-IN" sz="1400" b="1" dirty="0"/>
+              <a:t>Low </a:t>
+            </a:r>
+            <a:r>
+              <a:rPr lang="en-IN" sz="1400" b="1" dirty="0" err="1"/>
+              <a:t>CapEx</a:t>
+            </a:r>
+            <a:r>
+              <a:rPr lang="en-IN" sz="1400" b="1" dirty="0"/>
+              <a:t> &amp; Scalable:</a:t>
+            </a:r>
+            <a:r>
+              <a:rPr lang="en-IN" sz="1400" dirty="0"/>
+              <a:t> Indigenous hardware (&lt; ₹600) makes full-field sensor coverage affordable compared to expensive imported systems (₹50k+).</a:t>
+            </a:r>
+          </a:p>
+          <a:p>
+            <a:pPr lvl="0"/>
+            <a:r>
+              <a:rPr lang="en-IN" sz="1400" b="1" dirty="0"/>
+              <a:t>Environmental Benefits:</a:t>
+            </a:r>
+            <a:endParaRPr lang="en-IN" sz="1400" dirty="0"/>
+          </a:p>
+          <a:p>
+            <a:pPr lvl="1"/>
+            <a:r>
+              <a:rPr lang="en-IN" sz="1400" b="1" dirty="0"/>
+              <a:t>Groundwater &amp; Soil Protection:</a:t>
+            </a:r>
+            <a:r>
+              <a:rPr lang="en-IN" sz="1400" dirty="0"/>
+              <a:t> Early crack detection prevents groundwater table drainage and aquifer breach.</a:t>
+            </a:r>
+          </a:p>
+          <a:p>
+            <a:pPr lvl="1"/>
+            <a:r>
+              <a:rPr lang="en-IN" sz="1400" b="1" dirty="0"/>
+              <a:t>Fire Prevention:</a:t>
+            </a:r>
+            <a:r>
+              <a:rPr lang="en-IN" sz="1400" dirty="0"/>
+              <a:t> Reduces surface air ingress through fissures that trigger hazardous spontaneous coal-seam fires.</a:t>
+            </a:r>
+          </a:p>
+          <a:p>
+            <a:pPr lvl="0"/>
+            <a:r>
+              <a:rPr lang="en-IN" sz="1400" b="1" dirty="0"/>
+              <a:t>🇮🇳 Strategic / "Make in India":</a:t>
+            </a:r>
+            <a:endParaRPr lang="en-IN" sz="1400" dirty="0"/>
+          </a:p>
+          <a:p>
+            <a:pPr lvl="1"/>
+            <a:r>
+              <a:rPr lang="en-IN" sz="1400" dirty="0"/>
+              <a:t>Fully indigenous, low-power AI-IoT solution promoting smart, sustainable, and safe Indian coal mining.</a:t>
+            </a:r>
+          </a:p>
+          <a:p>
+            <a:endParaRPr lang="en-IN" sz="1400" dirty="0"/>
+          </a:p>
+        </p:txBody>
+      </p:sp>
+      <p:sp>
+        <p:nvSpPr>
+          <p:cNvPr id="9" name="TextBox 8">
+            <a:extLst>
+              <a:ext uri="{FF2B5EF4-FFF2-40B4-BE49-F238E27FC236}">
+                <a16:creationId xmlns:a16="http://schemas.microsoft.com/office/drawing/2014/main" id="{489F8CD4-294E-04EB-381B-1454B8C66F48}"/>
+              </a:ext>
+            </a:extLst>
+          </p:cNvPr>
+          <p:cNvSpPr txBox="1"/>
+          <p:nvPr/>
+        </p:nvSpPr>
+        <p:spPr>
+          <a:xfrm>
+            <a:off x="7108722" y="1037318"/>
+            <a:ext cx="4235134" cy="646331"/>
+          </a:xfrm>
+          <a:prstGeom prst="rect">
+            <a:avLst/>
+          </a:prstGeom>
+          <a:noFill/>
+        </p:spPr>
+        <p:txBody>
+          <a:bodyPr wrap="none" rtlCol="0">
+            <a:spAutoFit/>
+          </a:bodyPr>
+          <a:lstStyle/>
+          <a:p>
+            <a:r>
+              <a:rPr lang="en-IN" b="1" dirty="0"/>
+              <a:t>Impact on Target Audience &amp; Stakeholders</a:t>
+            </a:r>
+          </a:p>
+          <a:p>
+            <a:endParaRPr lang="en-IN" b="1" dirty="0"/>
+          </a:p>
+        </p:txBody>
+      </p:sp>
+      <p:sp>
+        <p:nvSpPr>
+          <p:cNvPr id="13" name="TextBox 12">
+            <a:extLst>
+              <a:ext uri="{FF2B5EF4-FFF2-40B4-BE49-F238E27FC236}">
+                <a16:creationId xmlns:a16="http://schemas.microsoft.com/office/drawing/2014/main" id="{20CA14F4-9E4C-E017-19F3-8221F453E4F6}"/>
+              </a:ext>
+            </a:extLst>
+          </p:cNvPr>
+          <p:cNvSpPr txBox="1"/>
+          <p:nvPr/>
+        </p:nvSpPr>
+        <p:spPr>
+          <a:xfrm>
+            <a:off x="1792995" y="986498"/>
+            <a:ext cx="2855205" cy="369332"/>
+          </a:xfrm>
+          <a:prstGeom prst="rect">
+            <a:avLst/>
+          </a:prstGeom>
+          <a:noFill/>
+        </p:spPr>
+        <p:txBody>
+          <a:bodyPr wrap="none" rtlCol="0">
+            <a:spAutoFit/>
+          </a:bodyPr>
+          <a:lstStyle/>
+          <a:p>
+            <a:r>
+              <a:rPr lang="en-IN" b="1" dirty="0"/>
+              <a:t> Multi-Dimensional Benefits</a:t>
+            </a:r>
           </a:p>
         </p:txBody>
       </p:sp>
@@ -10597,8 +10613,8 @@
         </p:nvSpPr>
         <p:spPr bwMode="auto">
           <a:xfrm>
-            <a:off x="609600" y="2137510"/>
-            <a:ext cx="9385300" cy="3139321"/>
+            <a:off x="973393" y="1696425"/>
+            <a:ext cx="10412361" cy="3970318"/>
           </a:xfrm>
           <a:prstGeom prst="rect">
             <a:avLst/>
@@ -10617,82 +10633,95 @@
           </a:bodyPr>
           <a:lstStyle/>
           <a:p>
-            <a:pPr marL="342900" indent="-342900" algn="just">
-              <a:buFont typeface="Arial" panose="020B0604020202020204" pitchFamily="34" charset="0"/>
-              <a:buChar char="•"/>
-            </a:pPr>
+            <a:pPr algn="just"/>
             <a:r>
               <a:rPr lang="en-US" dirty="0">
                 <a:latin typeface="Arial" pitchFamily="34" charset="0"/>
                 <a:cs typeface="Arial" pitchFamily="34" charset="0"/>
               </a:rPr>
-              <a:t>"On Underground Coal Mine Environment Monitoring with LoRa Range Extension," IEEE Xplore, 2023.</a:t>
-            </a:r>
-          </a:p>
-          <a:p>
-            <a:pPr marL="342900" indent="-342900" algn="just">
-              <a:buFont typeface="Arial" panose="020B0604020202020204" pitchFamily="34" charset="0"/>
-              <a:buChar char="•"/>
-            </a:pPr>
+              <a:t>[1] Wang et al., "Design of Wireless Sensor Networks for Real-Time Mining Safety Telemetry," IEEE Trans. Ind. Informatics.</a:t>
+            </a:r>
+          </a:p>
+          <a:p>
+            <a:pPr algn="just"/>
+            <a:endParaRPr lang="en-US" dirty="0">
+              <a:latin typeface="Arial" pitchFamily="34" charset="0"/>
+              <a:cs typeface="Arial" pitchFamily="34" charset="0"/>
+            </a:endParaRPr>
+          </a:p>
+          <a:p>
+            <a:pPr algn="just"/>
             <a:r>
               <a:rPr lang="en-US" dirty="0">
                 <a:latin typeface="Arial" pitchFamily="34" charset="0"/>
                 <a:cs typeface="Arial" pitchFamily="34" charset="0"/>
               </a:rPr>
-              <a:t>"On the Application of IoT: Slope Monitoring System for Open-cast Mines Based on LoRa Wireless Communication," Arabian Journal for Science and Engineering, Springer, 2021.</a:t>
-            </a:r>
-          </a:p>
-          <a:p>
-            <a:pPr marL="342900" indent="-342900" algn="just">
-              <a:buFont typeface="Arial" panose="020B0604020202020204" pitchFamily="34" charset="0"/>
-              <a:buChar char="•"/>
-            </a:pPr>
+              <a:t>[2]Chen et al., "Mining-Induced Ground Subsidence Prediction Using Machine Learning," Int. J. Min. Sci. Technol. (Elsevier).</a:t>
+            </a:r>
+          </a:p>
+          <a:p>
+            <a:pPr algn="just"/>
+            <a:endParaRPr lang="en-US" dirty="0">
+              <a:latin typeface="Arial" pitchFamily="34" charset="0"/>
+              <a:cs typeface="Arial" pitchFamily="34" charset="0"/>
+            </a:endParaRPr>
+          </a:p>
+          <a:p>
+            <a:pPr algn="just"/>
             <a:r>
               <a:rPr lang="en-US" dirty="0">
                 <a:latin typeface="Arial" pitchFamily="34" charset="0"/>
                 <a:cs typeface="Arial" pitchFamily="34" charset="0"/>
               </a:rPr>
-              <a:t>"Testing of LoRa Module for Communication Systems in Opencast Mine vis-à-vis Slope Stability," NIT Rourkela.</a:t>
-            </a:r>
-          </a:p>
-          <a:p>
-            <a:pPr marL="342900" indent="-342900" algn="just">
-              <a:buFont typeface="Arial" panose="020B0604020202020204" pitchFamily="34" charset="0"/>
-              <a:buChar char="•"/>
-            </a:pPr>
+              <a:t>[3] Das et al., "Low-Cost MEMS Sensor-Based Surface Tilt Monitoring for Geohazard Warning," IEEE Sensors Journal.</a:t>
+            </a:r>
+          </a:p>
+          <a:p>
+            <a:pPr algn="just"/>
+            <a:endParaRPr lang="en-US" dirty="0">
+              <a:latin typeface="Arial" pitchFamily="34" charset="0"/>
+              <a:cs typeface="Arial" pitchFamily="34" charset="0"/>
+            </a:endParaRPr>
+          </a:p>
+          <a:p>
+            <a:pPr algn="just"/>
             <a:r>
               <a:rPr lang="en-US" dirty="0">
                 <a:latin typeface="Arial" pitchFamily="34" charset="0"/>
                 <a:cs typeface="Arial" pitchFamily="34" charset="0"/>
               </a:rPr>
-              <a:t>"IoT </a:t>
+              <a:t>[4] Sharma et al., "Resilient Multi-Hop Wireless Mesh Networks for Mining Field Telemetry," IEEE IoT Journal.</a:t>
+            </a:r>
+          </a:p>
+          <a:p>
+            <a:pPr algn="just"/>
+            <a:endParaRPr lang="en-US" dirty="0">
+              <a:latin typeface="Arial" pitchFamily="34" charset="0"/>
+              <a:cs typeface="Arial" pitchFamily="34" charset="0"/>
+            </a:endParaRPr>
+          </a:p>
+          <a:p>
+            <a:pPr algn="just"/>
+            <a:r>
+              <a:rPr lang="en-US" dirty="0">
+                <a:latin typeface="Arial" pitchFamily="34" charset="0"/>
+                <a:cs typeface="Arial" pitchFamily="34" charset="0"/>
+              </a:rPr>
+              <a:t>[5] Tseng et al., "</a:t>
             </a:r>
             <a:r>
               <a:rPr lang="en-US" dirty="0" err="1">
                 <a:latin typeface="Arial" pitchFamily="34" charset="0"/>
                 <a:cs typeface="Arial" pitchFamily="34" charset="0"/>
               </a:rPr>
-              <a:t>LoRaWAN</a:t>
+              <a:t>TinyML</a:t>
             </a:r>
             <a:r>
               <a:rPr lang="en-US" dirty="0">
                 <a:latin typeface="Arial" pitchFamily="34" charset="0"/>
                 <a:cs typeface="Arial" pitchFamily="34" charset="0"/>
               </a:rPr>
-              <a:t>-Based Wireless Sensors Network for Underground Mine Monitoring," PMC, National Library of Medicine, 2024.</a:t>
-            </a:r>
-          </a:p>
-          <a:p>
-            <a:pPr marL="342900" indent="-342900" algn="just">
-              <a:buFont typeface="Arial" panose="020B0604020202020204" pitchFamily="34" charset="0"/>
-              <a:buChar char="•"/>
-            </a:pPr>
-            <a:r>
-              <a:rPr lang="en-US" dirty="0">
-                <a:latin typeface="Arial" pitchFamily="34" charset="0"/>
-                <a:cs typeface="Arial" pitchFamily="34" charset="0"/>
-              </a:rPr>
-              <a:t>Directorate General of Mines Safety (DGMS) and Coal India Limited – guidelines and technical reports on surface subsidence in underground coal mining.</a:t>
+              <a:t> and Edge-AI for Ultra-Low-Power Real-Time Geohazard Early Warning," IEEE Embedded Systems Letters.</a:t>
             </a:r>
           </a:p>
         </p:txBody>
@@ -10780,77 +10809,6 @@
           </a:p>
         </p:txBody>
       </p:sp>
-      <p:sp>
-        <p:nvSpPr>
-          <p:cNvPr id="7" name="Footer Placeholder 6"/>
-          <p:cNvSpPr>
-            <a:spLocks noGrp="1"/>
-          </p:cNvSpPr>
-          <p:nvPr>
-            <p:ph type="ftr" sz="quarter" idx="11"/>
-          </p:nvPr>
-        </p:nvSpPr>
-        <p:spPr>
-          <a:xfrm>
-            <a:off x="4648200" y="6356353"/>
-            <a:ext cx="3204000" cy="365125"/>
-          </a:xfrm>
-        </p:spPr>
-        <p:txBody>
-          <a:bodyPr/>
-          <a:lstStyle/>
-          <a:p>
-            <a:pPr marL="0" marR="0" lvl="0" indent="0" algn="ctr" defTabSz="457200" rtl="0" eaLnBrk="1" fontAlgn="auto" latinLnBrk="0" hangingPunct="1">
-              <a:lnSpc>
-                <a:spcPct val="100000"/>
-              </a:lnSpc>
-              <a:spcBef>
-                <a:spcPts val="0"/>
-              </a:spcBef>
-              <a:spcAft>
-                <a:spcPts val="0"/>
-              </a:spcAft>
-              <a:buClrTx/>
-              <a:buSzTx/>
-              <a:buFontTx/>
-              <a:buNone/>
-              <a:tabLst/>
-              <a:defRPr/>
-            </a:pPr>
-            <a:r>
-              <a:rPr kumimoji="0" lang="en-US" sz="1200" b="0" i="0" u="none" strike="noStrike" kern="1200" cap="none" spc="0" normalizeH="0" baseline="0" noProof="0">
-                <a:ln>
-                  <a:noFill/>
-                </a:ln>
-                <a:solidFill>
-                  <a:prstClr val="white"/>
-                </a:solidFill>
-                <a:effectLst/>
-                <a:uLnTx/>
-                <a:uFillTx/>
-                <a:latin typeface="TradeGothic"/>
-                <a:ea typeface="+mn-ea"/>
-                <a:cs typeface="+mn-cs"/>
-              </a:rPr>
-              <a:t>@SIH Idea submission- Template</a:t>
-            </a:r>
-            <a:endParaRPr kumimoji="0" lang="en-US" sz="1200" b="0" i="0" u="none" strike="noStrike" kern="1200" cap="none" spc="0" normalizeH="0" baseline="0" noProof="0" dirty="0">
-              <a:ln>
-                <a:noFill/>
-              </a:ln>
-              <a:solidFill>
-                <a:prstClr val="white"/>
-              </a:solidFill>
-              <a:effectLst/>
-              <a:uLnTx/>
-              <a:uFillTx/>
-              <a:latin typeface="TradeGothic"/>
-              <a:ea typeface="+mn-ea"/>
-              <a:cs typeface="+mn-cs"/>
-            </a:endParaRPr>
-          </a:p>
-        </p:txBody>
-      </p:sp>
       <p:pic>
         <p:nvPicPr>
           <p:cNvPr id="12" name="Picture 11"/>
@@ -10925,7 +10883,7 @@
           <a:p>
             <a:pPr algn="ctr"/>
             <a:r>
-              <a:rPr lang="en-US" sz="1600" dirty="0" err="1"/>
+              <a:rPr lang="en-US" sz="1600" dirty="0"/>
               <a:t>ForgeByte</a:t>
             </a:r>
             <a:endParaRPr lang="en-IN" sz="1600" dirty="0"/>

</xml_diff>